<commit_message>
Fix presentation shape layering
Co-authored-by: w450434204 <w450434204@users.noreply.github.com>
</commit_message>
<xml_diff>
--- a/鸿蒙支付开发者效率提升专项_ST汇报模板.pptx
+++ b/鸿蒙支付开发者效率提升专项_ST汇报模板.pptx
@@ -7745,46 +7745,7 @@
       </p:cxnSp>
       <p:sp>
         <p:nvSpPr>
-          <p:cNvPr id="5" name="TextBox 4"/>
-          <p:cNvSpPr txBox="1"/>
-          <p:nvPr/>
-        </p:nvSpPr>
-        <p:spPr>
-          <a:xfrm>
-            <a:off x="594360" y="1115568"/>
-            <a:ext cx="1051560" cy="292608"/>
-          </a:xfrm>
-          <a:prstGeom prst="rect">
-            <a:avLst/>
-          </a:prstGeom>
-          <a:noFill/>
-        </p:spPr>
-        <p:txBody>
-          <a:bodyPr wrap="square" lIns="54864" rIns="54864" tIns="54864" bIns="54864" anchor="ctr">
-            <a:spAutoFit/>
-          </a:bodyPr>
-          <a:lstStyle/>
-          <a:p>
-            <a:pPr algn="ctr">
-              <a:lnSpc>
-                <a:spcPct val="100000"/>
-              </a:lnSpc>
-            </a:pPr>
-            <a:r>
-              <a:rPr sz="1100" b="1">
-                <a:solidFill>
-                  <a:srgbClr val="FFFFFF"/>
-                </a:solidFill>
-                <a:latin typeface="Microsoft YaHei"/>
-              </a:rPr>
-              <a:t>一句话目标</a:t>
-            </a:r>
-          </a:p>
-        </p:txBody>
-      </p:sp>
-      <p:sp>
-        <p:nvSpPr>
-          <p:cNvPr id="6" name="Rounded Rectangle 5"/>
+          <p:cNvPr id="5" name="Rounded Rectangle 4"/>
           <p:cNvSpPr/>
           <p:nvPr/>
         </p:nvSpPr>
@@ -7824,6 +7785,45 @@
           <a:lstStyle/>
           <a:p>
             <a:pPr algn="ctr"/>
+          </a:p>
+        </p:txBody>
+      </p:sp>
+      <p:sp>
+        <p:nvSpPr>
+          <p:cNvPr id="6" name="TextBox 5"/>
+          <p:cNvSpPr txBox="1"/>
+          <p:nvPr/>
+        </p:nvSpPr>
+        <p:spPr>
+          <a:xfrm>
+            <a:off x="594360" y="1115568"/>
+            <a:ext cx="1051560" cy="292608"/>
+          </a:xfrm>
+          <a:prstGeom prst="rect">
+            <a:avLst/>
+          </a:prstGeom>
+          <a:noFill/>
+        </p:spPr>
+        <p:txBody>
+          <a:bodyPr wrap="square" lIns="54864" rIns="54864" tIns="54864" bIns="54864" anchor="ctr">
+            <a:spAutoFit/>
+          </a:bodyPr>
+          <a:lstStyle/>
+          <a:p>
+            <a:pPr algn="ctr">
+              <a:lnSpc>
+                <a:spcPct val="100000"/>
+              </a:lnSpc>
+            </a:pPr>
+            <a:r>
+              <a:rPr sz="1100" b="1">
+                <a:solidFill>
+                  <a:srgbClr val="FFFFFF"/>
+                </a:solidFill>
+                <a:latin typeface="Microsoft YaHei"/>
+              </a:rPr>
+              <a:t>一句话目标</a:t>
+            </a:r>
           </a:p>
         </p:txBody>
       </p:sp>
@@ -19893,46 +19893,7 @@
       </p:sp>
       <p:sp>
         <p:nvSpPr>
-          <p:cNvPr id="9" name="TextBox 8"/>
-          <p:cNvSpPr txBox="1"/>
-          <p:nvPr/>
-        </p:nvSpPr>
-        <p:spPr>
-          <a:xfrm>
-            <a:off x="1463040" y="4892040"/>
-            <a:ext cx="1691640" cy="411480"/>
-          </a:xfrm>
-          <a:prstGeom prst="rect">
-            <a:avLst/>
-          </a:prstGeom>
-          <a:noFill/>
-        </p:spPr>
-        <p:txBody>
-          <a:bodyPr wrap="square" lIns="54864" rIns="54864" tIns="54864" bIns="54864" anchor="ctr">
-            <a:spAutoFit/>
-          </a:bodyPr>
-          <a:lstStyle/>
-          <a:p>
-            <a:pPr algn="ctr">
-              <a:lnSpc>
-                <a:spcPct val="100000"/>
-              </a:lnSpc>
-            </a:pPr>
-            <a:r>
-              <a:rPr sz="1500" b="1">
-                <a:solidFill>
-                  <a:srgbClr val="FFFFFF"/>
-                </a:solidFill>
-                <a:latin typeface="Microsoft YaHei"/>
-              </a:rPr>
-              <a:t>开发完成</a:t>
-            </a:r>
-          </a:p>
-        </p:txBody>
-      </p:sp>
-      <p:sp>
-        <p:nvSpPr>
-          <p:cNvPr id="10" name="Rounded Rectangle 9"/>
+          <p:cNvPr id="9" name="Rounded Rectangle 8"/>
           <p:cNvSpPr/>
           <p:nvPr/>
         </p:nvSpPr>
@@ -19975,6 +19936,45 @@
           </a:p>
         </p:txBody>
       </p:sp>
+      <p:sp>
+        <p:nvSpPr>
+          <p:cNvPr id="10" name="TextBox 9"/>
+          <p:cNvSpPr txBox="1"/>
+          <p:nvPr/>
+        </p:nvSpPr>
+        <p:spPr>
+          <a:xfrm>
+            <a:off x="1463040" y="4892040"/>
+            <a:ext cx="1691640" cy="411480"/>
+          </a:xfrm>
+          <a:prstGeom prst="rect">
+            <a:avLst/>
+          </a:prstGeom>
+          <a:noFill/>
+        </p:spPr>
+        <p:txBody>
+          <a:bodyPr wrap="square" lIns="54864" rIns="54864" tIns="54864" bIns="54864" anchor="ctr">
+            <a:spAutoFit/>
+          </a:bodyPr>
+          <a:lstStyle/>
+          <a:p>
+            <a:pPr algn="ctr">
+              <a:lnSpc>
+                <a:spcPct val="100000"/>
+              </a:lnSpc>
+            </a:pPr>
+            <a:r>
+              <a:rPr sz="1500" b="1">
+                <a:solidFill>
+                  <a:srgbClr val="FFFFFF"/>
+                </a:solidFill>
+                <a:latin typeface="Microsoft YaHei"/>
+              </a:rPr>
+              <a:t>开发完成</a:t>
+            </a:r>
+          </a:p>
+        </p:txBody>
+      </p:sp>
       <p:cxnSp>
         <p:nvCxnSpPr>
           <p:cNvPr id="11" name="Connector 10"/>
@@ -20259,46 +20259,7 @@
       </p:sp>
       <p:sp>
         <p:nvSpPr>
-          <p:cNvPr id="16" name="TextBox 15"/>
-          <p:cNvSpPr txBox="1"/>
-          <p:nvPr/>
-        </p:nvSpPr>
-        <p:spPr>
-          <a:xfrm>
-            <a:off x="5230368" y="4892040"/>
-            <a:ext cx="1691640" cy="411480"/>
-          </a:xfrm>
-          <a:prstGeom prst="rect">
-            <a:avLst/>
-          </a:prstGeom>
-          <a:noFill/>
-        </p:spPr>
-        <p:txBody>
-          <a:bodyPr wrap="square" lIns="54864" rIns="54864" tIns="54864" bIns="54864" anchor="ctr">
-            <a:spAutoFit/>
-          </a:bodyPr>
-          <a:lstStyle/>
-          <a:p>
-            <a:pPr algn="ctr">
-              <a:lnSpc>
-                <a:spcPct val="100000"/>
-              </a:lnSpc>
-            </a:pPr>
-            <a:r>
-              <a:rPr sz="1500" b="1">
-                <a:solidFill>
-                  <a:srgbClr val="FFFFFF"/>
-                </a:solidFill>
-                <a:latin typeface="Microsoft YaHei"/>
-              </a:rPr>
-              <a:t>允许上线</a:t>
-            </a:r>
-          </a:p>
-        </p:txBody>
-      </p:sp>
-      <p:sp>
-        <p:nvSpPr>
-          <p:cNvPr id="17" name="Rounded Rectangle 16"/>
+          <p:cNvPr id="16" name="Rounded Rectangle 15"/>
           <p:cNvSpPr/>
           <p:nvPr/>
         </p:nvSpPr>
@@ -20341,6 +20302,45 @@
           </a:p>
         </p:txBody>
       </p:sp>
+      <p:sp>
+        <p:nvSpPr>
+          <p:cNvPr id="17" name="TextBox 16"/>
+          <p:cNvSpPr txBox="1"/>
+          <p:nvPr/>
+        </p:nvSpPr>
+        <p:spPr>
+          <a:xfrm>
+            <a:off x="5230368" y="4892040"/>
+            <a:ext cx="1691640" cy="411480"/>
+          </a:xfrm>
+          <a:prstGeom prst="rect">
+            <a:avLst/>
+          </a:prstGeom>
+          <a:noFill/>
+        </p:spPr>
+        <p:txBody>
+          <a:bodyPr wrap="square" lIns="54864" rIns="54864" tIns="54864" bIns="54864" anchor="ctr">
+            <a:spAutoFit/>
+          </a:bodyPr>
+          <a:lstStyle/>
+          <a:p>
+            <a:pPr algn="ctr">
+              <a:lnSpc>
+                <a:spcPct val="100000"/>
+              </a:lnSpc>
+            </a:pPr>
+            <a:r>
+              <a:rPr sz="1500" b="1">
+                <a:solidFill>
+                  <a:srgbClr val="FFFFFF"/>
+                </a:solidFill>
+                <a:latin typeface="Microsoft YaHei"/>
+              </a:rPr>
+              <a:t>允许上线</a:t>
+            </a:r>
+          </a:p>
+        </p:txBody>
+      </p:sp>
       <p:cxnSp>
         <p:nvCxnSpPr>
           <p:cNvPr id="18" name="Connector 17"/>
@@ -20625,46 +20625,7 @@
       </p:sp>
       <p:sp>
         <p:nvSpPr>
-          <p:cNvPr id="23" name="TextBox 22"/>
-          <p:cNvSpPr txBox="1"/>
-          <p:nvPr/>
-        </p:nvSpPr>
-        <p:spPr>
-          <a:xfrm>
-            <a:off x="8997696" y="4892040"/>
-            <a:ext cx="1691640" cy="411480"/>
-          </a:xfrm>
-          <a:prstGeom prst="rect">
-            <a:avLst/>
-          </a:prstGeom>
-          <a:noFill/>
-        </p:spPr>
-        <p:txBody>
-          <a:bodyPr wrap="square" lIns="54864" rIns="54864" tIns="54864" bIns="54864" anchor="ctr">
-            <a:spAutoFit/>
-          </a:bodyPr>
-          <a:lstStyle/>
-          <a:p>
-            <a:pPr algn="ctr">
-              <a:lnSpc>
-                <a:spcPct val="100000"/>
-              </a:lnSpc>
-            </a:pPr>
-            <a:r>
-              <a:rPr sz="1500" b="1">
-                <a:solidFill>
-                  <a:srgbClr val="FFFFFF"/>
-                </a:solidFill>
-                <a:latin typeface="Microsoft YaHei"/>
-              </a:rPr>
-              <a:t>持续稳定</a:t>
-            </a:r>
-          </a:p>
-        </p:txBody>
-      </p:sp>
-      <p:sp>
-        <p:nvSpPr>
-          <p:cNvPr id="24" name="Rounded Rectangle 23"/>
+          <p:cNvPr id="23" name="Rounded Rectangle 22"/>
           <p:cNvSpPr/>
           <p:nvPr/>
         </p:nvSpPr>
@@ -20704,6 +20665,45 @@
           <a:lstStyle/>
           <a:p>
             <a:pPr algn="ctr"/>
+          </a:p>
+        </p:txBody>
+      </p:sp>
+      <p:sp>
+        <p:nvSpPr>
+          <p:cNvPr id="24" name="TextBox 23"/>
+          <p:cNvSpPr txBox="1"/>
+          <p:nvPr/>
+        </p:nvSpPr>
+        <p:spPr>
+          <a:xfrm>
+            <a:off x="8997696" y="4892040"/>
+            <a:ext cx="1691640" cy="411480"/>
+          </a:xfrm>
+          <a:prstGeom prst="rect">
+            <a:avLst/>
+          </a:prstGeom>
+          <a:noFill/>
+        </p:spPr>
+        <p:txBody>
+          <a:bodyPr wrap="square" lIns="54864" rIns="54864" tIns="54864" bIns="54864" anchor="ctr">
+            <a:spAutoFit/>
+          </a:bodyPr>
+          <a:lstStyle/>
+          <a:p>
+            <a:pPr algn="ctr">
+              <a:lnSpc>
+                <a:spcPct val="100000"/>
+              </a:lnSpc>
+            </a:pPr>
+            <a:r>
+              <a:rPr sz="1500" b="1">
+                <a:solidFill>
+                  <a:srgbClr val="FFFFFF"/>
+                </a:solidFill>
+                <a:latin typeface="Microsoft YaHei"/>
+              </a:rPr>
+              <a:t>持续稳定</a:t>
+            </a:r>
           </a:p>
         </p:txBody>
       </p:sp>

</xml_diff>